<commit_message>
E2 slides: backup slide on how accuracy was measured
Co-Authored-By: Claude Opus 5.5 <noreply@anthropic.com>
</commit_message>
<xml_diff>
--- a/code/snn_keyword/research/reports/E2_network_size_slides.pptx
+++ b/code/snn_keyword/research/reports/E2_network_size_slides.pptx
@@ -10,6 +10,7 @@
     <p:sldId id="258" r:id="rId10"/>
     <p:sldId id="259" r:id="rId11"/>
     <p:sldId id="260" r:id="rId12"/>
+    <p:sldId id="261" r:id="rId13"/>
   </p:sldIdLst>
   <p:sldSz cx="12192000" cy="6858000" type="screen4x3"/>
   <p:notesSz cx="6858000" cy="9144000"/>
@@ -111,13 +112,18 @@
   <p:extLst>
     <p:ext uri="{521415D9-36F7-43E2-AB2F-B90AF26B5E84}">
       <p14:sectionLst xmlns:p14="http://schemas.microsoft.com/office/powerpoint/2010/main">
-        <p14:section name="Network size (E2)" id="{7E949986-12ED-4FA1-A813-0C2A8E7262D8}">
+        <p14:section name="Network size (E2)" id="{BD898679-0C7B-479D-A6B8-B7C7708539CB}">
           <p14:sldIdLst>
             <p14:sldId id="256"/>
             <p14:sldId id="257"/>
             <p14:sldId id="258"/>
             <p14:sldId id="259"/>
             <p14:sldId id="260"/>
+          </p14:sldIdLst>
+        </p14:section>
+        <p14:section name="Network size: backup" id="{D38E3FF4-0610-461D-A954-FF092B24B6EE}">
+          <p14:sldIdLst>
+            <p14:sldId id="261"/>
           </p14:sldIdLst>
         </p14:section>
       </p14:sectionLst>
@@ -1148,7 +1154,7 @@
                       </a:schemeClr>
                     </a:solidFill>
                   </a:rPr>
-                  <a:t>score</a:t>
+                  <a:t>F1 score / detection rate (%)</a:t>
                 </a:r>
               </a:p>
             </c:rich>
@@ -2484,6 +2490,76 @@
           <a:p>
             <a:r>
               <a:t>So 48 neurons give the same quality as 95 with half the memory and half the processing time: the efficient size for this design.</a:t>
+            </a:r>
+          </a:p>
+        </p:txBody>
+      </p:sp>
+      <p:sp>
+        <p:nvSpPr>
+          <p:cNvPr id="4" name="Slide Number Placeholder 3"/>
+          <p:cNvSpPr>
+            <a:spLocks noGrp="1"/>
+          </p:cNvSpPr>
+          <p:nvPr>
+            <p:ph type="sldNum" idx="5" sz="quarter"/>
+          </p:nvPr>
+        </p:nvSpPr>
+        <p:spPr/>
+      </p:sp>
+    </p:spTree>
+  </p:cSld>
+  <p:clrMapOvr>
+    <a:masterClrMapping/>
+  </p:clrMapOvr>
+</p:notes>
+</file>
+
+<file path=ppt/notesSlides/notesSlide6.xml><?xml version="1.0" encoding="utf-8"?>
+<p:notes xmlns:a="http://schemas.openxmlformats.org/drawingml/2006/main" xmlns:p="http://schemas.openxmlformats.org/presentationml/2006/main" xmlns:r="http://schemas.openxmlformats.org/officeDocument/2006/relationships">
+  <p:cSld>
+    <p:spTree>
+      <p:nvGrpSpPr>
+        <p:cNvPr id="1" name=""/>
+        <p:cNvGrpSpPr/>
+        <p:nvPr/>
+      </p:nvGrpSpPr>
+      <p:grpSpPr>
+        <a:xfrm>
+          <a:off x="0" y="0"/>
+          <a:ext cx="0" cy="0"/>
+          <a:chOff x="0" y="0"/>
+          <a:chExt cx="0" cy="0"/>
+        </a:xfrm>
+      </p:grpSpPr>
+      <p:sp>
+        <p:nvSpPr>
+          <p:cNvPr id="2" name="Slide Image Placeholder 1"/>
+          <p:cNvSpPr>
+            <a:spLocks noGrp="1"/>
+          </p:cNvSpPr>
+          <p:nvPr>
+            <p:ph type="sldImg" idx="2"/>
+          </p:nvPr>
+        </p:nvSpPr>
+        <p:spPr/>
+      </p:sp>
+      <p:sp>
+        <p:nvSpPr>
+          <p:cNvPr id="3" name="Notes Placeholder 2"/>
+          <p:cNvSpPr>
+            <a:spLocks noGrp="1"/>
+          </p:cNvSpPr>
+          <p:nvPr>
+            <p:ph type="body" idx="3" sz="quarter"/>
+          </p:nvPr>
+        </p:nvSpPr>
+        <p:spPr/>
+        <p:txBody>
+          <a:bodyPr/>
+          <a:lstStyle/>
+          <a:p>
+            <a:r>
+              <a:t>We measured accuracy with the F1 score on 11,005 test recordings from speakers the network never heard. F1 combines recall, how many real "Sheila"s it finds, and precision, how often a detection is actually right. We do not use plain accuracy: 98% of the clips are not "Sheila", so always saying "no" would already score 98%. The second line on the quality chart simulates the live demo: the share of real "Sheila"s that would light the LED.</a:t>
             </a:r>
           </a:p>
         </p:txBody>
@@ -10821,6 +10897,1032 @@
                 </a:solidFill>
               </a:rPr>
               <a:t>48 has the best mean validation F1 (chosen before looking at test results); its quality differences to 95 are within the spread of 3 runs.</a:t>
+            </a:r>
+          </a:p>
+        </p:txBody>
+      </p:sp>
+    </p:spTree>
+  </p:cSld>
+  <p:clrMapOvr>
+    <a:masterClrMapping/>
+  </p:clrMapOvr>
+</p:sld>
+</file>
+
+<file path=ppt/slides/slide6.xml><?xml version="1.0" encoding="utf-8"?>
+<p:sld xmlns:a="http://schemas.openxmlformats.org/drawingml/2006/main" xmlns:p="http://schemas.openxmlformats.org/presentationml/2006/main" xmlns:r="http://schemas.openxmlformats.org/officeDocument/2006/relationships">
+  <p:cSld>
+    <p:spTree>
+      <p:nvGrpSpPr>
+        <p:cNvPr id="1" name=""/>
+        <p:cNvGrpSpPr/>
+        <p:nvPr/>
+      </p:nvGrpSpPr>
+      <p:grpSpPr/>
+      <p:sp>
+        <p:nvSpPr>
+          <p:cNvPr id="2" name="Title 1"/>
+          <p:cNvSpPr>
+            <a:spLocks noGrp="1"/>
+          </p:cNvSpPr>
+          <p:nvPr>
+            <p:ph type="title"/>
+          </p:nvPr>
+        </p:nvSpPr>
+        <p:spPr/>
+        <p:txBody>
+          <a:bodyPr/>
+          <a:lstStyle/>
+          <a:p>
+            <a:r>
+              <a:t>Backup: how accuracy was measured</a:t>
+            </a:r>
+          </a:p>
+        </p:txBody>
+      </p:sp>
+      <p:graphicFrame>
+        <p:nvGraphicFramePr>
+          <p:cNvPr id="3" name="Confusion matrix"/>
+          <p:cNvGraphicFramePr>
+            <a:graphicFrameLocks noGrp="1"/>
+          </p:cNvGraphicFramePr>
+          <p:nvPr/>
+        </p:nvGraphicFramePr>
+        <p:xfrm>
+          <a:off x="548640" y="1463040"/>
+          <a:ext cx="5760720" cy="2606040"/>
+        </p:xfrm>
+        <a:graphic>
+          <a:graphicData uri="http://schemas.openxmlformats.org/drawingml/2006/table">
+            <a:tbl>
+              <a:tblPr>
+                <a:tableStyleId>{5C22544A-7EE6-4342-B048-85BDC9FD1C3A}</a:tableStyleId>
+              </a:tblPr>
+              <a:tblGrid>
+                <a:gridCol w="2286000"/>
+                <a:gridCol w="1737360"/>
+                <a:gridCol w="1737360"/>
+              </a:tblGrid>
+              <a:tr h="594360">
+                <a:tc>
+                  <a:txBody>
+                    <a:bodyPr/>
+                    <a:lstStyle/>
+                    <a:p>
+                      <a:pPr algn="l"/>
+                      <a:r>
+                        <a:rPr sz="1600" b="0">
+                          <a:solidFill>
+                            <a:schemeClr val="tx2"/>
+                          </a:solidFill>
+                        </a:rPr>
+                        <a:t/>
+                      </a:r>
+                    </a:p>
+                  </a:txBody>
+                  <a:tcPr anchor="ctr" marL="164592" marR="164592" marT="45720" marB="45720">
+                    <a:solidFill>
+                      <a:schemeClr val="bg1"/>
+                    </a:solidFill>
+                  </a:tcPr>
+                </a:tc>
+                <a:tc>
+                  <a:txBody>
+                    <a:bodyPr/>
+                    <a:lstStyle/>
+                    <a:p>
+                      <a:pPr algn="ctr"/>
+                      <a:r>
+                        <a:rPr sz="1500" b="1">
+                          <a:solidFill>
+                            <a:schemeClr val="bg1"/>
+                          </a:solidFill>
+                        </a:rPr>
+                        <a:t>Network says "Sheila"</a:t>
+                      </a:r>
+                    </a:p>
+                  </a:txBody>
+                  <a:tcPr anchor="ctr" marL="164592" marR="164592" marT="45720" marB="45720">
+                    <a:solidFill>
+                      <a:schemeClr val="tx2"/>
+                    </a:solidFill>
+                  </a:tcPr>
+                </a:tc>
+                <a:tc>
+                  <a:txBody>
+                    <a:bodyPr/>
+                    <a:lstStyle/>
+                    <a:p>
+                      <a:pPr algn="ctr"/>
+                      <a:r>
+                        <a:rPr sz="1500" b="1">
+                          <a:solidFill>
+                            <a:schemeClr val="bg1"/>
+                          </a:solidFill>
+                        </a:rPr>
+                        <a:t>Network says "not Sheila"</a:t>
+                      </a:r>
+                    </a:p>
+                  </a:txBody>
+                  <a:tcPr anchor="ctr" marL="164592" marR="164592" marT="45720" marB="45720">
+                    <a:solidFill>
+                      <a:schemeClr val="tx2"/>
+                    </a:solidFill>
+                  </a:tcPr>
+                </a:tc>
+              </a:tr>
+              <a:tr h="1005840">
+                <a:tc>
+                  <a:txBody>
+                    <a:bodyPr/>
+                    <a:lstStyle/>
+                    <a:p>
+                      <a:pPr algn="l"/>
+                      <a:r>
+                        <a:rPr sz="1600" b="1">
+                          <a:solidFill>
+                            <a:schemeClr val="tx2"/>
+                          </a:solidFill>
+                        </a:rPr>
+                        <a:t>Really "Sheila"</a:t>
+                      </a:r>
+                    </a:p>
+                    <a:p>
+                      <a:pPr algn="l"/>
+                      <a:r>
+                        <a:rPr sz="1200" b="0">
+                          <a:solidFill>
+                            <a:schemeClr val="tx2">
+                              <a:lumMod val="70000"/>
+                              <a:lumOff val="30000"/>
+                            </a:schemeClr>
+                          </a:solidFill>
+                        </a:rPr>
+                        <a:t>212 recordings</a:t>
+                      </a:r>
+                    </a:p>
+                  </a:txBody>
+                  <a:tcPr anchor="ctr" marL="164592" marR="164592" marT="45720" marB="45720">
+                    <a:solidFill>
+                      <a:schemeClr val="bg2"/>
+                    </a:solidFill>
+                  </a:tcPr>
+                </a:tc>
+                <a:tc>
+                  <a:txBody>
+                    <a:bodyPr/>
+                    <a:lstStyle/>
+                    <a:p>
+                      <a:pPr algn="ctr"/>
+                      <a:r>
+                        <a:rPr sz="2400" b="1">
+                          <a:solidFill>
+                            <a:schemeClr val="tx2"/>
+                          </a:solidFill>
+                        </a:rPr>
+                        <a:t>160</a:t>
+                      </a:r>
+                    </a:p>
+                    <a:p>
+                      <a:pPr algn="ctr"/>
+                      <a:r>
+                        <a:rPr sz="1200" b="0">
+                          <a:solidFill>
+                            <a:schemeClr val="tx2">
+                              <a:lumMod val="70000"/>
+                              <a:lumOff val="30000"/>
+                            </a:schemeClr>
+                          </a:solidFill>
+                        </a:rPr>
+                        <a:t>found</a:t>
+                      </a:r>
+                    </a:p>
+                  </a:txBody>
+                  <a:tcPr anchor="ctr" marL="164592" marR="164592" marT="45720" marB="45720">
+                    <a:solidFill>
+                      <a:schemeClr val="accent1">
+                        <a:lumMod val="15000"/>
+                        <a:lumOff val="85000"/>
+                      </a:schemeClr>
+                    </a:solidFill>
+                  </a:tcPr>
+                </a:tc>
+                <a:tc>
+                  <a:txBody>
+                    <a:bodyPr/>
+                    <a:lstStyle/>
+                    <a:p>
+                      <a:pPr algn="ctr"/>
+                      <a:r>
+                        <a:rPr sz="2400" b="1">
+                          <a:solidFill>
+                            <a:schemeClr val="tx2"/>
+                          </a:solidFill>
+                        </a:rPr>
+                        <a:t>52</a:t>
+                      </a:r>
+                    </a:p>
+                    <a:p>
+                      <a:pPr algn="ctr"/>
+                      <a:r>
+                        <a:rPr sz="1200" b="0">
+                          <a:solidFill>
+                            <a:schemeClr val="tx2">
+                              <a:lumMod val="70000"/>
+                              <a:lumOff val="30000"/>
+                            </a:schemeClr>
+                          </a:solidFill>
+                        </a:rPr>
+                        <a:t>missed</a:t>
+                      </a:r>
+                    </a:p>
+                  </a:txBody>
+                  <a:tcPr anchor="ctr" marL="164592" marR="164592" marT="45720" marB="45720">
+                    <a:solidFill>
+                      <a:schemeClr val="accent2">
+                        <a:lumMod val="15000"/>
+                        <a:lumOff val="85000"/>
+                      </a:schemeClr>
+                    </a:solidFill>
+                  </a:tcPr>
+                </a:tc>
+              </a:tr>
+              <a:tr h="1005840">
+                <a:tc>
+                  <a:txBody>
+                    <a:bodyPr/>
+                    <a:lstStyle/>
+                    <a:p>
+                      <a:pPr algn="l"/>
+                      <a:r>
+                        <a:rPr sz="1600" b="1">
+                          <a:solidFill>
+                            <a:schemeClr val="tx2"/>
+                          </a:solidFill>
+                        </a:rPr>
+                        <a:t>Really another word</a:t>
+                      </a:r>
+                    </a:p>
+                    <a:p>
+                      <a:pPr algn="l"/>
+                      <a:r>
+                        <a:rPr sz="1200" b="0">
+                          <a:solidFill>
+                            <a:schemeClr val="tx2">
+                              <a:lumMod val="70000"/>
+                              <a:lumOff val="30000"/>
+                            </a:schemeClr>
+                          </a:solidFill>
+                        </a:rPr>
+                        <a:t>10,793 recordings</a:t>
+                      </a:r>
+                    </a:p>
+                  </a:txBody>
+                  <a:tcPr anchor="ctr" marL="164592" marR="164592" marT="45720" marB="45720">
+                    <a:solidFill>
+                      <a:schemeClr val="bg2"/>
+                    </a:solidFill>
+                  </a:tcPr>
+                </a:tc>
+                <a:tc>
+                  <a:txBody>
+                    <a:bodyPr/>
+                    <a:lstStyle/>
+                    <a:p>
+                      <a:pPr algn="ctr"/>
+                      <a:r>
+                        <a:rPr sz="2400" b="1">
+                          <a:solidFill>
+                            <a:schemeClr val="tx2"/>
+                          </a:solidFill>
+                        </a:rPr>
+                        <a:t>37</a:t>
+                      </a:r>
+                    </a:p>
+                    <a:p>
+                      <a:pPr algn="ctr"/>
+                      <a:r>
+                        <a:rPr sz="1200" b="0">
+                          <a:solidFill>
+                            <a:schemeClr val="tx2">
+                              <a:lumMod val="70000"/>
+                              <a:lumOff val="30000"/>
+                            </a:schemeClr>
+                          </a:solidFill>
+                        </a:rPr>
+                        <a:t>false alarms</a:t>
+                      </a:r>
+                    </a:p>
+                  </a:txBody>
+                  <a:tcPr anchor="ctr" marL="164592" marR="164592" marT="45720" marB="45720">
+                    <a:solidFill>
+                      <a:schemeClr val="accent2">
+                        <a:lumMod val="15000"/>
+                        <a:lumOff val="85000"/>
+                      </a:schemeClr>
+                    </a:solidFill>
+                  </a:tcPr>
+                </a:tc>
+                <a:tc>
+                  <a:txBody>
+                    <a:bodyPr/>
+                    <a:lstStyle/>
+                    <a:p>
+                      <a:pPr algn="ctr"/>
+                      <a:r>
+                        <a:rPr sz="2400" b="1">
+                          <a:solidFill>
+                            <a:schemeClr val="tx2"/>
+                          </a:solidFill>
+                        </a:rPr>
+                        <a:t>10,756</a:t>
+                      </a:r>
+                    </a:p>
+                    <a:p>
+                      <a:pPr algn="ctr"/>
+                      <a:r>
+                        <a:rPr sz="1200" b="0">
+                          <a:solidFill>
+                            <a:schemeClr val="tx2">
+                              <a:lumMod val="70000"/>
+                              <a:lumOff val="30000"/>
+                            </a:schemeClr>
+                          </a:solidFill>
+                        </a:rPr>
+                        <a:t>correctly rejected</a:t>
+                      </a:r>
+                    </a:p>
+                  </a:txBody>
+                  <a:tcPr anchor="ctr" marL="164592" marR="164592" marT="45720" marB="45720">
+                    <a:solidFill>
+                      <a:schemeClr val="bg2"/>
+                    </a:solidFill>
+                  </a:tcPr>
+                </a:tc>
+              </a:tr>
+            </a:tbl>
+          </a:graphicData>
+        </a:graphic>
+      </p:graphicFrame>
+      <p:sp>
+        <p:nvSpPr>
+          <p:cNvPr id="4" name="TextBox 3"/>
+          <p:cNvSpPr txBox="1"/>
+          <p:nvPr/>
+        </p:nvSpPr>
+        <p:spPr>
+          <a:xfrm>
+            <a:off x="548640" y="4160520"/>
+            <a:ext cx="5760720" cy="411480"/>
+          </a:xfrm>
+          <a:prstGeom prst="rect">
+            <a:avLst/>
+          </a:prstGeom>
+          <a:noFill/>
+        </p:spPr>
+        <p:txBody>
+          <a:bodyPr wrap="square" lIns="0" rIns="0" tIns="0" bIns="0" anchor="t">
+            <a:spAutoFit/>
+          </a:bodyPr>
+          <a:lstStyle/>
+          <a:p>
+            <a:pPr algn="l"/>
+            <a:r>
+              <a:rPr sz="1200" b="0" i="0">
+                <a:solidFill>
+                  <a:schemeClr val="tx1">
+                    <a:lumMod val="70000"/>
+                    <a:lumOff val="30000"/>
+                  </a:schemeClr>
+                </a:solidFill>
+              </a:rPr>
+              <a:t>Deployed model (95 neurons) on the 11,005 test recordings, from speakers never heard in training</a:t>
+            </a:r>
+          </a:p>
+        </p:txBody>
+      </p:sp>
+      <p:sp>
+        <p:nvSpPr>
+          <p:cNvPr id="5" name="Recall"/>
+          <p:cNvSpPr/>
+          <p:nvPr/>
+        </p:nvSpPr>
+        <p:spPr>
+          <a:xfrm>
+            <a:off x="6629400" y="1463040"/>
+            <a:ext cx="5010912" cy="822960"/>
+          </a:xfrm>
+          <a:prstGeom prst="roundRect">
+            <a:avLst>
+              <a:gd name="adj" fmla="val 12000"/>
+            </a:avLst>
+          </a:prstGeom>
+          <a:solidFill>
+            <a:schemeClr val="bg2"/>
+          </a:solidFill>
+          <a:ln>
+            <a:noFill/>
+          </a:ln>
+          <a:effectLst/>
+        </p:spPr>
+        <p:style>
+          <a:lnRef idx="1">
+            <a:schemeClr val="accent1"/>
+          </a:lnRef>
+          <a:fillRef idx="3">
+            <a:schemeClr val="accent1"/>
+          </a:fillRef>
+          <a:effectRef idx="2">
+            <a:schemeClr val="accent1"/>
+          </a:effectRef>
+          <a:fontRef idx="minor">
+            <a:schemeClr val="lt1"/>
+          </a:fontRef>
+        </p:style>
+        <p:txBody>
+          <a:bodyPr rtlCol="0" anchor="ctr"/>
+          <a:lstStyle/>
+          <a:p>
+            <a:pPr algn="ctr"/>
+          </a:p>
+        </p:txBody>
+      </p:sp>
+      <p:sp>
+        <p:nvSpPr>
+          <p:cNvPr id="6" name="TextBox 5"/>
+          <p:cNvSpPr txBox="1"/>
+          <p:nvPr/>
+        </p:nvSpPr>
+        <p:spPr>
+          <a:xfrm>
+            <a:off x="6903720" y="1463040"/>
+            <a:ext cx="1600200" cy="822960"/>
+          </a:xfrm>
+          <a:prstGeom prst="rect">
+            <a:avLst/>
+          </a:prstGeom>
+          <a:noFill/>
+        </p:spPr>
+        <p:txBody>
+          <a:bodyPr wrap="square" lIns="0" rIns="0" tIns="0" bIns="0" anchor="ctr">
+            <a:spAutoFit/>
+          </a:bodyPr>
+          <a:lstStyle/>
+          <a:p>
+            <a:pPr algn="l"/>
+            <a:r>
+              <a:rPr sz="3000" b="1" i="0">
+                <a:solidFill>
+                  <a:schemeClr val="tx2"/>
+                </a:solidFill>
+              </a:rPr>
+              <a:t>75.5%</a:t>
+            </a:r>
+          </a:p>
+        </p:txBody>
+      </p:sp>
+      <p:sp>
+        <p:nvSpPr>
+          <p:cNvPr id="7" name="TextBox 6"/>
+          <p:cNvSpPr txBox="1"/>
+          <p:nvPr/>
+        </p:nvSpPr>
+        <p:spPr>
+          <a:xfrm>
+            <a:off x="8686800" y="1463040"/>
+            <a:ext cx="2679191" cy="822960"/>
+          </a:xfrm>
+          <a:prstGeom prst="rect">
+            <a:avLst/>
+          </a:prstGeom>
+          <a:noFill/>
+        </p:spPr>
+        <p:txBody>
+          <a:bodyPr wrap="square" lIns="0" rIns="0" tIns="0" bIns="0" anchor="ctr">
+            <a:spAutoFit/>
+          </a:bodyPr>
+          <a:lstStyle/>
+          <a:p>
+            <a:pPr algn="l"/>
+            <a:r>
+              <a:rPr sz="1400" b="0" i="0">
+                <a:solidFill>
+                  <a:schemeClr val="tx1">
+                    <a:lumMod val="75000"/>
+                    <a:lumOff val="25000"/>
+                  </a:schemeClr>
+                </a:solidFill>
+              </a:rPr>
+              <a:t>Recall: "Sheila"s found</a:t>
+            </a:r>
+          </a:p>
+          <a:p>
+            <a:pPr algn="l"/>
+            <a:r>
+              <a:rPr sz="1400" b="0" i="0">
+                <a:solidFill>
+                  <a:schemeClr val="tx1">
+                    <a:lumMod val="75000"/>
+                    <a:lumOff val="25000"/>
+                  </a:schemeClr>
+                </a:solidFill>
+              </a:rPr>
+              <a:t>160 / 212</a:t>
+            </a:r>
+          </a:p>
+        </p:txBody>
+      </p:sp>
+      <p:sp>
+        <p:nvSpPr>
+          <p:cNvPr id="8" name="Precision"/>
+          <p:cNvSpPr/>
+          <p:nvPr/>
+        </p:nvSpPr>
+        <p:spPr>
+          <a:xfrm>
+            <a:off x="6629400" y="2377440"/>
+            <a:ext cx="5010912" cy="822960"/>
+          </a:xfrm>
+          <a:prstGeom prst="roundRect">
+            <a:avLst>
+              <a:gd name="adj" fmla="val 12000"/>
+            </a:avLst>
+          </a:prstGeom>
+          <a:solidFill>
+            <a:schemeClr val="bg2"/>
+          </a:solidFill>
+          <a:ln>
+            <a:noFill/>
+          </a:ln>
+          <a:effectLst/>
+        </p:spPr>
+        <p:style>
+          <a:lnRef idx="1">
+            <a:schemeClr val="accent1"/>
+          </a:lnRef>
+          <a:fillRef idx="3">
+            <a:schemeClr val="accent1"/>
+          </a:fillRef>
+          <a:effectRef idx="2">
+            <a:schemeClr val="accent1"/>
+          </a:effectRef>
+          <a:fontRef idx="minor">
+            <a:schemeClr val="lt1"/>
+          </a:fontRef>
+        </p:style>
+        <p:txBody>
+          <a:bodyPr rtlCol="0" anchor="ctr"/>
+          <a:lstStyle/>
+          <a:p>
+            <a:pPr algn="ctr"/>
+          </a:p>
+        </p:txBody>
+      </p:sp>
+      <p:sp>
+        <p:nvSpPr>
+          <p:cNvPr id="9" name="TextBox 8"/>
+          <p:cNvSpPr txBox="1"/>
+          <p:nvPr/>
+        </p:nvSpPr>
+        <p:spPr>
+          <a:xfrm>
+            <a:off x="6903720" y="2377440"/>
+            <a:ext cx="1600200" cy="822960"/>
+          </a:xfrm>
+          <a:prstGeom prst="rect">
+            <a:avLst/>
+          </a:prstGeom>
+          <a:noFill/>
+        </p:spPr>
+        <p:txBody>
+          <a:bodyPr wrap="square" lIns="0" rIns="0" tIns="0" bIns="0" anchor="ctr">
+            <a:spAutoFit/>
+          </a:bodyPr>
+          <a:lstStyle/>
+          <a:p>
+            <a:pPr algn="l"/>
+            <a:r>
+              <a:rPr sz="3000" b="1" i="0">
+                <a:solidFill>
+                  <a:schemeClr val="tx2"/>
+                </a:solidFill>
+              </a:rPr>
+              <a:t>81.2%</a:t>
+            </a:r>
+          </a:p>
+        </p:txBody>
+      </p:sp>
+      <p:sp>
+        <p:nvSpPr>
+          <p:cNvPr id="10" name="TextBox 9"/>
+          <p:cNvSpPr txBox="1"/>
+          <p:nvPr/>
+        </p:nvSpPr>
+        <p:spPr>
+          <a:xfrm>
+            <a:off x="8686800" y="2377440"/>
+            <a:ext cx="2679191" cy="822960"/>
+          </a:xfrm>
+          <a:prstGeom prst="rect">
+            <a:avLst/>
+          </a:prstGeom>
+          <a:noFill/>
+        </p:spPr>
+        <p:txBody>
+          <a:bodyPr wrap="square" lIns="0" rIns="0" tIns="0" bIns="0" anchor="ctr">
+            <a:spAutoFit/>
+          </a:bodyPr>
+          <a:lstStyle/>
+          <a:p>
+            <a:pPr algn="l"/>
+            <a:r>
+              <a:rPr sz="1400" b="0" i="0">
+                <a:solidFill>
+                  <a:schemeClr val="tx1">
+                    <a:lumMod val="75000"/>
+                    <a:lumOff val="25000"/>
+                  </a:schemeClr>
+                </a:solidFill>
+              </a:rPr>
+              <a:t>Precision: right detections</a:t>
+            </a:r>
+          </a:p>
+          <a:p>
+            <a:pPr algn="l"/>
+            <a:r>
+              <a:rPr sz="1400" b="0" i="0">
+                <a:solidFill>
+                  <a:schemeClr val="tx1">
+                    <a:lumMod val="75000"/>
+                    <a:lumOff val="25000"/>
+                  </a:schemeClr>
+                </a:solidFill>
+              </a:rPr>
+              <a:t>160 / (160 + 37)</a:t>
+            </a:r>
+          </a:p>
+        </p:txBody>
+      </p:sp>
+      <p:sp>
+        <p:nvSpPr>
+          <p:cNvPr id="11" name="F1"/>
+          <p:cNvSpPr/>
+          <p:nvPr/>
+        </p:nvSpPr>
+        <p:spPr>
+          <a:xfrm>
+            <a:off x="6629400" y="3291840"/>
+            <a:ext cx="5010912" cy="822960"/>
+          </a:xfrm>
+          <a:prstGeom prst="roundRect">
+            <a:avLst>
+              <a:gd name="adj" fmla="val 12000"/>
+            </a:avLst>
+          </a:prstGeom>
+          <a:solidFill>
+            <a:schemeClr val="bg2"/>
+          </a:solidFill>
+          <a:ln>
+            <a:noFill/>
+          </a:ln>
+          <a:effectLst/>
+        </p:spPr>
+        <p:style>
+          <a:lnRef idx="1">
+            <a:schemeClr val="accent1"/>
+          </a:lnRef>
+          <a:fillRef idx="3">
+            <a:schemeClr val="accent1"/>
+          </a:fillRef>
+          <a:effectRef idx="2">
+            <a:schemeClr val="accent1"/>
+          </a:effectRef>
+          <a:fontRef idx="minor">
+            <a:schemeClr val="lt1"/>
+          </a:fontRef>
+        </p:style>
+        <p:txBody>
+          <a:bodyPr rtlCol="0" anchor="ctr"/>
+          <a:lstStyle/>
+          <a:p>
+            <a:pPr algn="ctr"/>
+          </a:p>
+        </p:txBody>
+      </p:sp>
+      <p:sp>
+        <p:nvSpPr>
+          <p:cNvPr id="12" name="TextBox 11"/>
+          <p:cNvSpPr txBox="1"/>
+          <p:nvPr/>
+        </p:nvSpPr>
+        <p:spPr>
+          <a:xfrm>
+            <a:off x="6903720" y="3291840"/>
+            <a:ext cx="1600200" cy="822960"/>
+          </a:xfrm>
+          <a:prstGeom prst="rect">
+            <a:avLst/>
+          </a:prstGeom>
+          <a:noFill/>
+        </p:spPr>
+        <p:txBody>
+          <a:bodyPr wrap="square" lIns="0" rIns="0" tIns="0" bIns="0" anchor="ctr">
+            <a:spAutoFit/>
+          </a:bodyPr>
+          <a:lstStyle/>
+          <a:p>
+            <a:pPr algn="l"/>
+            <a:r>
+              <a:rPr sz="3000" b="1" i="0">
+                <a:solidFill>
+                  <a:schemeClr val="tx2"/>
+                </a:solidFill>
+              </a:rPr>
+              <a:t>78.2%</a:t>
+            </a:r>
+          </a:p>
+        </p:txBody>
+      </p:sp>
+      <p:sp>
+        <p:nvSpPr>
+          <p:cNvPr id="13" name="TextBox 12"/>
+          <p:cNvSpPr txBox="1"/>
+          <p:nvPr/>
+        </p:nvSpPr>
+        <p:spPr>
+          <a:xfrm>
+            <a:off x="8686800" y="3291840"/>
+            <a:ext cx="2679191" cy="822960"/>
+          </a:xfrm>
+          <a:prstGeom prst="rect">
+            <a:avLst/>
+          </a:prstGeom>
+          <a:noFill/>
+        </p:spPr>
+        <p:txBody>
+          <a:bodyPr wrap="square" lIns="0" rIns="0" tIns="0" bIns="0" anchor="ctr">
+            <a:spAutoFit/>
+          </a:bodyPr>
+          <a:lstStyle/>
+          <a:p>
+            <a:pPr algn="l"/>
+            <a:r>
+              <a:rPr sz="1400" b="0" i="0">
+                <a:solidFill>
+                  <a:schemeClr val="tx1">
+                    <a:lumMod val="75000"/>
+                    <a:lumOff val="25000"/>
+                  </a:schemeClr>
+                </a:solidFill>
+              </a:rPr>
+              <a:t>F1: combines both</a:t>
+            </a:r>
+          </a:p>
+          <a:p>
+            <a:pPr algn="l"/>
+            <a:r>
+              <a:rPr sz="1400" b="0" i="0">
+                <a:solidFill>
+                  <a:schemeClr val="tx1">
+                    <a:lumMod val="75000"/>
+                    <a:lumOff val="25000"/>
+                  </a:schemeClr>
+                </a:solidFill>
+              </a:rPr>
+              <a:t>2 × P × R / (P + R)</a:t>
+            </a:r>
+          </a:p>
+        </p:txBody>
+      </p:sp>
+      <p:sp>
+        <p:nvSpPr>
+          <p:cNvPr id="14" name="Why not plain accuracy?"/>
+          <p:cNvSpPr/>
+          <p:nvPr/>
+        </p:nvSpPr>
+        <p:spPr>
+          <a:xfrm>
+            <a:off x="548640" y="4663440"/>
+            <a:ext cx="5468112" cy="1463040"/>
+          </a:xfrm>
+          <a:prstGeom prst="roundRect">
+            <a:avLst>
+              <a:gd name="adj" fmla="val 11249"/>
+            </a:avLst>
+          </a:prstGeom>
+          <a:solidFill>
+            <a:schemeClr val="bg2"/>
+          </a:solidFill>
+          <a:ln>
+            <a:noFill/>
+          </a:ln>
+          <a:effectLst/>
+        </p:spPr>
+        <p:style>
+          <a:lnRef idx="1">
+            <a:schemeClr val="accent1"/>
+          </a:lnRef>
+          <a:fillRef idx="3">
+            <a:schemeClr val="accent1"/>
+          </a:fillRef>
+          <a:effectRef idx="2">
+            <a:schemeClr val="accent1"/>
+          </a:effectRef>
+          <a:fontRef idx="minor">
+            <a:schemeClr val="lt1"/>
+          </a:fontRef>
+        </p:style>
+        <p:txBody>
+          <a:bodyPr rtlCol="0" anchor="ctr"/>
+          <a:lstStyle/>
+          <a:p>
+            <a:pPr algn="ctr"/>
+          </a:p>
+        </p:txBody>
+      </p:sp>
+      <p:sp>
+        <p:nvSpPr>
+          <p:cNvPr id="15" name="TextBox 14"/>
+          <p:cNvSpPr txBox="1"/>
+          <p:nvPr/>
+        </p:nvSpPr>
+        <p:spPr>
+          <a:xfrm>
+            <a:off x="822959" y="4846320"/>
+            <a:ext cx="4919472" cy="1143000"/>
+          </a:xfrm>
+          <a:prstGeom prst="rect">
+            <a:avLst/>
+          </a:prstGeom>
+          <a:noFill/>
+        </p:spPr>
+        <p:txBody>
+          <a:bodyPr wrap="square" lIns="0" rIns="0" tIns="0" bIns="0" anchor="t">
+            <a:spAutoFit/>
+          </a:bodyPr>
+          <a:lstStyle/>
+          <a:p>
+            <a:pPr algn="l"/>
+            <a:r>
+              <a:rPr sz="1600" b="1" i="0">
+                <a:solidFill>
+                  <a:schemeClr val="tx2"/>
+                </a:solidFill>
+              </a:rPr>
+              <a:t>Why not plain accuracy?</a:t>
+            </a:r>
+          </a:p>
+          <a:p>
+            <a:pPr algn="l">
+              <a:spcBef>
+                <a:spcPts val="400"/>
+              </a:spcBef>
+            </a:pPr>
+            <a:r>
+              <a:rPr sz="1400" b="0" i="0">
+                <a:solidFill>
+                  <a:schemeClr val="tx1">
+                    <a:lumMod val="80000"/>
+                    <a:lumOff val="20000"/>
+                  </a:schemeClr>
+                </a:solidFill>
+              </a:rPr>
+              <a:t>98% of the clips are not "Sheila": always answering "no" already scores 98.1%. Ours scores 99.2%, which hides the 52 misses.</a:t>
+            </a:r>
+          </a:p>
+        </p:txBody>
+      </p:sp>
+      <p:sp>
+        <p:nvSpPr>
+          <p:cNvPr id="16" name="Live detection (orange line)"/>
+          <p:cNvSpPr/>
+          <p:nvPr/>
+        </p:nvSpPr>
+        <p:spPr>
+          <a:xfrm>
+            <a:off x="6172200" y="4663440"/>
+            <a:ext cx="5468112" cy="1463040"/>
+          </a:xfrm>
+          <a:prstGeom prst="roundRect">
+            <a:avLst>
+              <a:gd name="adj" fmla="val 11249"/>
+            </a:avLst>
+          </a:prstGeom>
+          <a:solidFill>
+            <a:schemeClr val="bg2"/>
+          </a:solidFill>
+          <a:ln>
+            <a:noFill/>
+          </a:ln>
+          <a:effectLst/>
+        </p:spPr>
+        <p:style>
+          <a:lnRef idx="1">
+            <a:schemeClr val="accent1"/>
+          </a:lnRef>
+          <a:fillRef idx="3">
+            <a:schemeClr val="accent1"/>
+          </a:fillRef>
+          <a:effectRef idx="2">
+            <a:schemeClr val="accent1"/>
+          </a:effectRef>
+          <a:fontRef idx="minor">
+            <a:schemeClr val="lt1"/>
+          </a:fontRef>
+        </p:style>
+        <p:txBody>
+          <a:bodyPr rtlCol="0" anchor="ctr"/>
+          <a:lstStyle/>
+          <a:p>
+            <a:pPr algn="ctr"/>
+          </a:p>
+        </p:txBody>
+      </p:sp>
+      <p:sp>
+        <p:nvSpPr>
+          <p:cNvPr id="17" name="TextBox 16"/>
+          <p:cNvSpPr txBox="1"/>
+          <p:nvPr/>
+        </p:nvSpPr>
+        <p:spPr>
+          <a:xfrm>
+            <a:off x="6446520" y="4846320"/>
+            <a:ext cx="4919472" cy="1143000"/>
+          </a:xfrm>
+          <a:prstGeom prst="rect">
+            <a:avLst/>
+          </a:prstGeom>
+          <a:noFill/>
+        </p:spPr>
+        <p:txBody>
+          <a:bodyPr wrap="square" lIns="0" rIns="0" tIns="0" bIns="0" anchor="t">
+            <a:spAutoFit/>
+          </a:bodyPr>
+          <a:lstStyle/>
+          <a:p>
+            <a:pPr algn="l"/>
+            <a:r>
+              <a:rPr sz="1600" b="1" i="0">
+                <a:solidFill>
+                  <a:schemeClr val="tx2"/>
+                </a:solidFill>
+              </a:rPr>
+              <a:t>Live detection (orange line)</a:t>
+            </a:r>
+          </a:p>
+          <a:p>
+            <a:pPr algn="l">
+              <a:spcBef>
+                <a:spcPts val="400"/>
+              </a:spcBef>
+            </a:pPr>
+            <a:r>
+              <a:rPr sz="1400" b="0" i="0">
+                <a:solidFill>
+                  <a:schemeClr val="tx1">
+                    <a:lumMod val="80000"/>
+                    <a:lumOff val="20000"/>
+                  </a:schemeClr>
+                </a:solidFill>
+              </a:rPr>
+              <a:t>Test clips in background noise, cut into 1 s windows every 250 ms; detected if "2 of 3" fires: 61% of "Sheila"s found, 0.3% of other words accepted.</a:t>
+            </a:r>
+          </a:p>
+        </p:txBody>
+      </p:sp>
+      <p:sp>
+        <p:nvSpPr>
+          <p:cNvPr id="18" name="Footnote"/>
+          <p:cNvSpPr txBox="1"/>
+          <p:nvPr/>
+        </p:nvSpPr>
+        <p:spPr>
+          <a:xfrm>
+            <a:off x="548640" y="6263640"/>
+            <a:ext cx="11091672" cy="274320"/>
+          </a:xfrm>
+          <a:prstGeom prst="rect">
+            <a:avLst/>
+          </a:prstGeom>
+          <a:noFill/>
+        </p:spPr>
+        <p:txBody>
+          <a:bodyPr wrap="square" lIns="0" rIns="0" tIns="0" bIns="0" anchor="t">
+            <a:spAutoFit/>
+          </a:bodyPr>
+          <a:lstStyle/>
+          <a:p>
+            <a:pPr algn="l"/>
+            <a:r>
+              <a:rPr sz="1100" b="0" i="0">
+                <a:solidFill>
+                  <a:schemeClr val="tx1">
+                    <a:lumMod val="60000"/>
+                    <a:lumOff val="40000"/>
+                  </a:schemeClr>
+                </a:solidFill>
+              </a:rPr>
+              <a:t>Thresholds are chosen on separate validation recordings, never on the test set. The charts show the mean of 3 training runs; this table is the deployed run.</a:t>
             </a:r>
           </a:p>
         </p:txBody>

</xml_diff>